<commit_message>
Update others directory (process moves, skip .md and heavy .mp4 files)
</commit_message>
<xml_diff>
--- a/others/CSE499B_Review_Presentation.pptx
+++ b/others/CSE499B_Review_Presentation.pptx
@@ -15530,7 +15530,7 @@
                 <a:ea typeface="IBM Plex Sans" pitchFamily="34" charset="-122"/>
                 <a:cs typeface="IBM Plex Sans" pitchFamily="34" charset="-120"/>
               </a:rPr>
-              <a:t>· Aryan Sami</a:t>
+              <a:t>·</a:t>
             </a:r>
             <a:endParaRPr lang="en-US" sz="1200" dirty="0"/>
           </a:p>
@@ -15835,7 +15835,7 @@
                 <a:ea typeface="IBM Plex Sans" pitchFamily="34" charset="-122"/>
                 <a:cs typeface="IBM Plex Sans" pitchFamily="34" charset="-120"/>
               </a:rPr>
-              <a:t>· Tamanna Akter Mou</a:t>
+              <a:t>·</a:t>
             </a:r>
             <a:endParaRPr lang="en-US" sz="1200" dirty="0"/>
           </a:p>
@@ -16140,7 +16140,7 @@
                 <a:ea typeface="IBM Plex Sans" pitchFamily="34" charset="-122"/>
                 <a:cs typeface="IBM Plex Sans" pitchFamily="34" charset="-120"/>
               </a:rPr>
-              <a:t>· Abdullah Al Noman</a:t>
+              <a:t>·</a:t>
             </a:r>
             <a:endParaRPr lang="en-US" sz="1200" dirty="0"/>
           </a:p>
@@ -16445,7 +16445,7 @@
                 <a:ea typeface="IBM Plex Sans" pitchFamily="34" charset="-122"/>
                 <a:cs typeface="IBM Plex Sans" pitchFamily="34" charset="-120"/>
               </a:rPr>
-              <a:t>· Ridita Afrin Riya</a:t>
+              <a:t>·</a:t>
             </a:r>
             <a:endParaRPr lang="en-US" sz="1200" dirty="0"/>
           </a:p>

</xml_diff>